<commit_message>
added an explanation of what arcade does
</commit_message>
<xml_diff>
--- a/module-02-line-tracking/slides/05-proportional-control.pptx
+++ b/module-02-line-tracking/slides/05-proportional-control.pptx
@@ -5243,7 +5243,7 @@
               </a:defRPr>
             </a:pPr>
             <a:r>
-              <a:t>Continuous control (new): Sets motor power and returns immediately</a:t>
+              <a:t>Continuous control with set_effort(): Sets each motor's power individually</a:t>
             </a:r>
             <a:endParaRPr sz="2000"/>
           </a:p>
@@ -5266,7 +5266,7 @@
               <a:defRPr sz="2000"/>
             </a:pPr>
             <a:r>
-              <a:t>You can read sensors in between calls</a:t>
+              <a:t>Values range from -1.0 (full reverse) to 1.0 (full forward)</a:t>
             </a:r>
           </a:p>
         </p:txBody>
@@ -5477,7 +5477,7 @@
           <a:p>
             <a:pPr/>
             <a:r>
-              <a:t>drivetrain.set_effort(0.3, 0.3)  # Sets motors and CONTINUES</a:t>
+              <a:t>drivetrain.set_effort(0.3, 0.3)   # Sets left and right motors</a:t>
             </a:r>
           </a:p>
         </p:txBody>
@@ -5524,7 +5524,7 @@
           <a:p>
             <a:pPr/>
             <a:r>
-              <a:t>Key difference: arcade() does not block -- the program keeps running.</a:t>
+              <a:t>Key difference: set_effort() does not block -- the program keeps running.</a:t>
             </a:r>
           </a:p>
         </p:txBody>
@@ -5636,7 +5636,7 @@
           <a:p>
             <a:pPr/>
             <a:r>
-              <a:t>arcade() — Speed and Steering</a:t>
+              <a:t>arcade() — A Shortcut for Steering</a:t>
             </a:r>
           </a:p>
         </p:txBody>
@@ -5680,7 +5680,7 @@
           <a:p>
             <a:pPr/>
             <a:r>
-              <a:t>Drive straight:</a:t>
+              <a:t>Steering with set_effort() requires math:</a:t>
             </a:r>
           </a:p>
         </p:txBody>
@@ -5724,7 +5724,7 @@
           <a:p>
             <a:pPr/>
             <a:r>
-              <a:t>Steer right:</a:t>
+              <a:t>arcade() does this for you:</a:t>
             </a:r>
           </a:p>
         </p:txBody>
@@ -5768,7 +5768,7 @@
           <a:p>
             <a:pPr/>
             <a:r>
-              <a:t>Steer left:</a:t>
+              <a:t/>
             </a:r>
           </a:p>
         </p:txBody>
@@ -5812,7 +5812,7 @@
           <a:p>
             <a:pPr/>
             <a:r>
-              <a:t>Stop:</a:t>
+              <a:t/>
             </a:r>
           </a:p>
         </p:txBody>
@@ -5854,7 +5854,7 @@
               </a:defRPr>
             </a:pPr>
             <a:r>
-              <a:t>Under the hood: arcade(speed, turn) sets left motor to speed + turn and right motor to speed - turn.</a:t>
+              <a:t>arcade(speed, turn) is equivalent to set_effort(speed + turn, speed - turn)</a:t>
             </a:r>
           </a:p>
           <a:p>
@@ -5887,7 +5887,7 @@
               </a:defRPr>
             </a:pPr>
             <a:r>
-              <a:t>Question: "What would arcade(0.3, 0.15) do to each motor?" (Left = 0.45, Right = 0.15)</a:t>
+              <a:t>Question: "What set_effort() call is arcade(0.3, 0.1) equivalent to?" (set_effort(0.4, 0.2))</a:t>
             </a:r>
           </a:p>
         </p:txBody>
@@ -5984,7 +5984,7 @@
           <a:p>
             <a:pPr/>
             <a:r>
-              <a:t>drivetrain.arcade(0.3, 0)      # Forward, no turning</a:t>
+              <a:t>set_effort(0.3 + 0.15, 0.3 - 0.15)  # Steer right</a:t>
             </a:r>
           </a:p>
         </p:txBody>
@@ -6081,7 +6081,7 @@
           <a:p>
             <a:pPr/>
             <a:r>
-              <a:t>drivetrain.arcade(0.3, 0.15)   # Forward + steer right</a:t>
+              <a:t>arcade(0.3, 0.15)  # Same thing!</a:t>
             </a:r>
           </a:p>
         </p:txBody>
@@ -6178,7 +6178,7 @@
           <a:p>
             <a:pPr/>
             <a:r>
-              <a:t>drivetrain.arcade(0.3, -0.15)  # Forward + steer left</a:t>
+              <a:t>arcade(0.3, -0.15)  # Steer left</a:t>
             </a:r>
           </a:p>
         </p:txBody>
@@ -6275,7 +6275,7 @@
           <a:p>
             <a:pPr/>
             <a:r>
-              <a:t>drivetrain.stop()                  # Both motors off</a:t>
+              <a:t>arcade(0.3, 0)  # Drive straight</a:t>
             </a:r>
           </a:p>
         </p:txBody>

</xml_diff>